<commit_message>
docs: add real screenshots to deck and README; honest need-weighted slide
</commit_message>
<xml_diff>
--- a/docs/NagarVaani-pitch-deck.pptx
+++ b/docs/NagarVaani-pitch-deck.pptx
@@ -118,276 +118,6 @@
 </p:presentation>
 </file>
 
-<file path=ppt/charts/chart1.xml><?xml version="1.0" encoding="utf-8"?>
-<c:chartSpace xmlns:c="http://schemas.openxmlformats.org/drawingml/2006/chart" xmlns:a="http://schemas.openxmlformats.org/drawingml/2006/main" xmlns:r="http://schemas.openxmlformats.org/officeDocument/2006/relationships">
-  <c:date1904 val="0"/>
-  <c:roundedCorners val="1"/>
-  <c:chart>
-    <c:title>
-      <c:tx>
-        <c:rich>
-          <a:bodyPr/>
-          <a:lstStyle/>
-          <a:p>
-            <a:pPr>
-              <a:defRPr sz="1300" b="0" i="0" u="none" strike="noStrike">
-                <a:solidFill>
-                  <a:srgbClr val="E2E8F0"/>
-                </a:solidFill>
-                <a:latin typeface="Calibri"/>
-              </a:defRPr>
-            </a:pPr>
-            <a:r>
-              <a:rPr sz="1300" b="0" i="0" u="none" strike="noStrike">
-                <a:solidFill>
-                  <a:srgbClr val="E2E8F0"/>
-                </a:solidFill>
-                <a:latin typeface="Calibri"/>
-              </a:rPr>
-              <a:t>Places gained in rank (raw rank to need rank)</a:t>
-            </a:r>
-          </a:p>
-        </c:rich>
-      </c:tx>
-      <c:layout/>
-      <c:overlay val="0"/>
-    </c:title>
-    <c:autoTitleDeleted val="0"/>
-    <c:plotArea>
-      <c:layout/>
-      <c:barChart>
-        <c:barDir val="bar"/>
-        <c:grouping val="clustered"/>
-        <c:varyColors val="0"/>
-        <c:ser>
-          <c:idx val="0"/>
-          <c:order val="0"/>
-          <c:tx>
-            <c:strRef>
-              <c:f>Sheet1!$B$1</c:f>
-              <c:strCache>
-                <c:ptCount val="1"/>
-                <c:pt idx="0">
-                  <c:v>Places gained</c:v>
-                </c:pt>
-              </c:strCache>
-            </c:strRef>
-          </c:tx>
-          <c:spPr>
-            <a:solidFill>
-              <a:srgbClr val="8B5CF6"/>
-            </a:solidFill>
-            <a:effectLst/>
-          </c:spPr>
-          <c:invertIfNegative val="0"/>
-          <c:dLbls>
-            <c:numFmt formatCode="#,##0" sourceLinked="0"/>
-            <c:txPr>
-              <a:bodyPr/>
-              <a:lstStyle/>
-              <a:p>
-                <a:pPr>
-                  <a:defRPr b="0" i="0" strike="noStrike" sz="1300" u="none">
-                    <a:solidFill>
-                      <a:srgbClr val="FFFFFF"/>
-                    </a:solidFill>
-                    <a:latin typeface="Arial"/>
-                  </a:defRPr>
-                </a:pPr>
-              </a:p>
-            </c:txPr>
-            <c:showLegendKey val="0"/>
-            <c:showVal val="1"/>
-            <c:showCatName val="0"/>
-            <c:showSerName val="0"/>
-            <c:showPercent val="0"/>
-            <c:showBubbleSize val="0"/>
-            <c:showLeaderLines val="0"/>
-          </c:dLbls>
-          <c:cat>
-            <c:multiLvlStrRef>
-              <c:f>Sheet1!$A$2:$A$6</c:f>
-              <c:multiLvlStrCache>
-                <c:ptCount val="5"/>
-                <c:lvl>
-                  <c:pt idx="0">
-                    <c:v>Wayanad, Kerala</c:v>
-                  </c:pt>
-                  <c:pt idx="1">
-                    <c:v>Narmada, Gujarat</c:v>
-                  </c:pt>
-                  <c:pt idx="2">
-                    <c:v>Jaisalmer, Rajasthan</c:v>
-                  </c:pt>
-                  <c:pt idx="3">
-                    <c:v>Bijapur, Chhattisgarh</c:v>
-                  </c:pt>
-                  <c:pt idx="4">
-                    <c:v>Chamba, Himachal Pradesh</c:v>
-                  </c:pt>
-                </c:lvl>
-              </c:multiLvlStrCache>
-            </c:multiLvlStrRef>
-          </c:cat>
-          <c:val>
-            <c:numRef>
-              <c:f>Sheet1!$B$2:$B$6</c:f>
-              <c:numCache>
-                <c:formatCode>General</c:formatCode>
-                <c:ptCount val="5"/>
-                <c:pt idx="0">
-                  <c:v>31</c:v>
-                </c:pt>
-                <c:pt idx="1">
-                  <c:v>25</c:v>
-                </c:pt>
-                <c:pt idx="2">
-                  <c:v>15</c:v>
-                </c:pt>
-                <c:pt idx="3">
-                  <c:v>11</c:v>
-                </c:pt>
-                <c:pt idx="4">
-                  <c:v>11</c:v>
-                </c:pt>
-              </c:numCache>
-            </c:numRef>
-          </c:val>
-        </c:ser>
-        <c:dLbls>
-          <c:numFmt formatCode="#,##0" sourceLinked="0"/>
-          <c:txPr>
-            <a:bodyPr/>
-            <a:lstStyle/>
-            <a:p>
-              <a:pPr>
-                <a:defRPr b="0" i="0" strike="noStrike" sz="1300" u="none">
-                  <a:solidFill>
-                    <a:srgbClr val="FFFFFF"/>
-                  </a:solidFill>
-                  <a:latin typeface="Arial"/>
-                </a:defRPr>
-              </a:pPr>
-            </a:p>
-          </c:txPr>
-          <c:showLegendKey val="0"/>
-          <c:showVal val="1"/>
-          <c:showCatName val="0"/>
-          <c:showSerName val="0"/>
-          <c:showPercent val="0"/>
-          <c:showBubbleSize val="0"/>
-          <c:showLeaderLines val="0"/>
-        </c:dLbls>
-        <c:gapWidth val="45"/>
-        <c:overlap val="0"/>
-        <c:axId val="2094734554"/>
-        <c:axId val="2094734552"/>
-        <c:axId val="2094734556"/>
-      </c:barChart>
-      <c:catAx>
-        <c:axId val="2094734554"/>
-        <c:scaling>
-          <c:orientation val="maxMin"/>
-        </c:scaling>
-        <c:delete val="0"/>
-        <c:axPos val="l"/>
-        <c:numFmt formatCode="General" sourceLinked="1"/>
-        <c:majorTickMark val="out"/>
-        <c:minorTickMark val="none"/>
-        <c:tickLblPos val="nextTo"/>
-        <c:spPr>
-          <a:ln w="12700" cap="flat">
-            <a:solidFill>
-              <a:srgbClr val="888888"/>
-            </a:solidFill>
-            <a:prstDash val="solid"/>
-            <a:round/>
-          </a:ln>
-        </c:spPr>
-        <c:txPr>
-          <a:bodyPr/>
-          <a:lstStyle/>
-          <a:p>
-            <a:pPr>
-              <a:defRPr sz="1200" b="0" i="0" u="none" strike="noStrike">
-                <a:solidFill>
-                  <a:srgbClr val="E2E8F0"/>
-                </a:solidFill>
-                <a:latin typeface="Calibri"/>
-              </a:defRPr>
-            </a:pPr>
-            <a:endParaRPr lang="en-US"/>
-          </a:p>
-        </c:txPr>
-        <c:crossAx val="2094734552"/>
-        <c:crosses val="autoZero"/>
-        <c:auto val="1"/>
-        <c:lblAlgn val="ctr"/>
-        <c:noMultiLvlLbl val="1"/>
-      </c:catAx>
-      <c:valAx>
-        <c:axId val="2094734552"/>
-        <c:scaling>
-          <c:orientation val="minMax"/>
-        </c:scaling>
-        <c:delete val="1"/>
-        <c:axPos val="b"/>
-        <c:numFmt formatCode="General" sourceLinked="0"/>
-        <c:majorTickMark val="out"/>
-        <c:minorTickMark val="none"/>
-        <c:tickLblPos val="low"/>
-        <c:spPr>
-          <a:ln w="12700" cap="flat">
-            <a:solidFill>
-              <a:srgbClr val="888888"/>
-            </a:solidFill>
-            <a:prstDash val="solid"/>
-            <a:round/>
-          </a:ln>
-        </c:spPr>
-        <c:txPr>
-          <a:bodyPr/>
-          <a:lstStyle/>
-          <a:p>
-            <a:pPr>
-              <a:defRPr sz="1200" b="0" i="0" u="none" strike="noStrike">
-                <a:solidFill>
-                  <a:srgbClr val="000000"/>
-                </a:solidFill>
-                <a:latin typeface="Arial"/>
-              </a:defRPr>
-            </a:pPr>
-            <a:endParaRPr lang="en-US"/>
-          </a:p>
-        </c:txPr>
-        <c:crossAx val="2094734554"/>
-        <c:crosses val="autoZero"/>
-        <c:crossBetween val="between"/>
-      </c:valAx>
-      <c:spPr>
-        <a:noFill/>
-        <a:ln>
-          <a:noFill/>
-        </a:ln>
-        <a:effectLst/>
-      </c:spPr>
-    </c:plotArea>
-    <c:plotVisOnly val="1"/>
-    <c:dispBlanksAs val="span"/>
-  </c:chart>
-  <c:spPr>
-    <a:noFill/>
-    <a:ln>
-      <a:noFill/>
-    </a:ln>
-    <a:effectLst/>
-  </c:spPr>
-  <c:externalData r:id="rId1">
-    <c:autoUpdate val="0"/>
-  </c:externalData>
-</c:chartSpace>
-</file>
-
 <file path=ppt/notesMasters/notesMaster1.xml><?xml version="1.0" encoding="utf-8"?>
 <p:notesMaster xmlns:a="http://schemas.openxmlformats.org/drawingml/2006/main" xmlns:r="http://schemas.openxmlformats.org/officeDocument/2006/relationships" xmlns:p="http://schemas.openxmlformats.org/presentationml/2006/main">
   <p:cSld>
@@ -1575,7 +1305,7 @@
           <a:p>
             <a:r>
               <a:rPr lang="en-US" dirty="0"/>
-              <a:t>Figures come from the live demo's prioritisation endpoint on synthetic seed data using the rule-based engine (no Gemini key needed for the demo run). Say so if asked. Wayanad moves from 35th by raw count to 4th by need.</a:t>
+              <a:t>Screenshot of the Priority Interventions view on synthetic demo data (rule-based engine, no Gemini key needed for this view). Be upfront: each cluster has one complaint, so raw rank is a tie-break. The point is the mechanism: per-100k need, deprivation and aspirational flags, with Census 2011 population and NFHS-5 where loaded.</a:t>
             </a:r>
             <a:endParaRPr lang="en-US" dirty="0"/>
           </a:p>
@@ -1663,7 +1393,7 @@
           <a:p>
             <a:r>
               <a:rPr lang="en-US" dirty="0"/>
-              <a:t>Take four phone-width screenshots on the live URL: citizen portal, tracking page, dashboard heatmap, priority rankings. Delete the dashed frames and drop the images in.</a:t>
+              <a:t>Real screenshots from the live demo (synthetic data). Left: citizen portal on a phone. Right: dashboard heatmap and the department SLA centre where complaints are auto-routed to nodal departments.</a:t>
             </a:r>
             <a:endParaRPr lang="en-US" dirty="0"/>
           </a:p>
@@ -1751,7 +1481,7 @@
           <a:p>
             <a:r>
               <a:rPr lang="en-US" dirty="0"/>
-              <a:t>Judges score depth and reach across India. Seed data is synthetic; the point is that adding districts means adding rows to the data layer.</a:t>
+              <a:t>The BRICS comparison is an extension to show the same engine works with other countries by changing data, not code. Its records are marked synthetic. Do not quote population or beneficiary figures from that view unless you can source them.</a:t>
             </a:r>
             <a:endParaRPr lang="en-US" dirty="0"/>
           </a:p>
@@ -10026,7 +9756,7 @@
                 <a:ea typeface="Calibri" pitchFamily="34" charset="-122"/>
                 <a:cs typeface="Calibri" pitchFamily="34" charset="-120"/>
               </a:rPr>
-              <a:t>Need-weighted ranking changes who gets seen</a:t>
+              <a:t>Need-weighted ranking re-orders priorities</a:t>
             </a:r>
             <a:endParaRPr lang="en-US" sz="3800" dirty="0"/>
           </a:p>
@@ -10065,42 +9795,77 @@
                 <a:ea typeface="Calibri" pitchFamily="34" charset="-122"/>
                 <a:cs typeface="Calibri" pitchFamily="34" charset="-120"/>
               </a:rPr>
-              <a:t>Live demo output on synthetic data: rank gained versus raw complaint count</a:t>
+              <a:t>Live demo screen (synthetic complaints): need per head and deprivation, not raw volume</a:t>
             </a:r>
             <a:endParaRPr lang="en-US" sz="1600" dirty="0"/>
           </a:p>
         </p:txBody>
       </p:sp>
-      <p:graphicFrame>
-        <p:nvGraphicFramePr>
-          <p:cNvPr id="4" name="Chart 0" descr=""/>
-          <p:cNvGraphicFramePr/>
-          <p:nvPr/>
-        </p:nvGraphicFramePr>
-        <p:xfrm>
-          <a:off x="548640" y="1783080"/>
-          <a:ext cx="6675120" cy="4206240"/>
-        </p:xfrm>
-        <a:graphic xmlns:a="http://schemas.openxmlformats.org/drawingml/2006/main">
-          <a:graphicData uri="http://schemas.openxmlformats.org/drawingml/2006/chart">
-            <c:chart xmlns:c="http://schemas.openxmlformats.org/drawingml/2006/chart" r:id="rId1"/>
-          </a:graphicData>
-        </a:graphic>
-      </p:graphicFrame>
-      <p:sp>
-        <p:nvSpPr>
-          <p:cNvPr id="5" name="Shape 2"/>
+      <p:sp>
+        <p:nvSpPr>
+          <p:cNvPr id="4" name="Shape 2"/>
           <p:cNvSpPr/>
           <p:nvPr/>
         </p:nvSpPr>
         <p:spPr>
           <a:xfrm>
-            <a:off x="7589520" y="1783080"/>
-            <a:ext cx="3977640" cy="2286000"/>
+            <a:off x="640080" y="1783080"/>
+            <a:ext cx="8138160" cy="3639312"/>
           </a:xfrm>
           <a:prstGeom prst="roundRect">
             <a:avLst>
-              <a:gd name="adj" fmla="val 4800"/>
+              <a:gd name="adj" fmla="val 2010"/>
+            </a:avLst>
+          </a:prstGeom>
+          <a:solidFill>
+            <a:srgbClr val="0F0F1A"/>
+          </a:solidFill>
+          <a:ln w="9525">
+            <a:solidFill>
+              <a:srgbClr val="2A2A4A"/>
+            </a:solidFill>
+            <a:prstDash val="solid"/>
+          </a:ln>
+        </p:spPr>
+      </p:sp>
+      <p:pic>
+        <p:nvPicPr>
+          <p:cNvPr id="5" name="Image 0" descr="/tmp/deck/shots/priority.png">    </p:cNvPr>
+          <p:cNvPicPr>
+            <a:picLocks noChangeAspect="1"/>
+          </p:cNvPicPr>
+          <p:nvPr/>
+        </p:nvPicPr>
+        <p:blipFill>
+          <a:blip r:embed="rId1"/>
+          <a:stretch>
+            <a:fillRect/>
+          </a:stretch>
+        </p:blipFill>
+        <p:spPr>
+          <a:xfrm>
+            <a:off x="713232" y="1856232"/>
+            <a:ext cx="7991856" cy="3439725"/>
+          </a:xfrm>
+          <a:prstGeom prst="rect">
+            <a:avLst/>
+          </a:prstGeom>
+        </p:spPr>
+      </p:pic>
+      <p:sp>
+        <p:nvSpPr>
+          <p:cNvPr id="6" name="Shape 3"/>
+          <p:cNvSpPr/>
+          <p:nvPr/>
+        </p:nvSpPr>
+        <p:spPr>
+          <a:xfrm>
+            <a:off x="9052560" y="1783080"/>
+            <a:ext cx="2514600" cy="2057400"/>
+          </a:xfrm>
+          <a:prstGeom prst="roundRect">
+            <a:avLst>
+              <a:gd name="adj" fmla="val 5333"/>
             </a:avLst>
           </a:prstGeom>
           <a:solidFill>
@@ -10123,14 +9888,14 @@
       </p:sp>
       <p:sp>
         <p:nvSpPr>
-          <p:cNvPr id="6" name="Text 3"/>
-          <p:cNvSpPr txBox="1"/>
-          <p:nvPr/>
-        </p:nvSpPr>
-        <p:spPr>
-          <a:xfrm>
-            <a:off x="7818120" y="1901952"/>
-            <a:ext cx="3566160" cy="365760"/>
+          <p:cNvPr id="7" name="Text 4"/>
+          <p:cNvSpPr txBox="1"/>
+          <p:nvPr/>
+        </p:nvSpPr>
+        <p:spPr>
+          <a:xfrm>
+            <a:off x="9235440" y="1874520"/>
+            <a:ext cx="2194560" cy="365760"/>
           </a:xfrm>
           <a:prstGeom prst="rect">
             <a:avLst/>
@@ -10146,7 +9911,7 @@
               <a:buNone/>
             </a:pPr>
             <a:r>
-              <a:rPr lang="en-US" sz="1700" b="1" dirty="0">
+              <a:rPr lang="en-US" sz="1500" b="1" dirty="0">
                 <a:solidFill>
                   <a:srgbClr val="FFFFFF"/>
                 </a:solidFill>
@@ -10156,20 +9921,20 @@
               </a:rPr>
               <a:t>Need-weighted score</a:t>
             </a:r>
-            <a:endParaRPr lang="en-US" sz="1700" dirty="0"/>
-          </a:p>
-        </p:txBody>
-      </p:sp>
-      <p:sp>
-        <p:nvSpPr>
-          <p:cNvPr id="7" name="Text 4"/>
-          <p:cNvSpPr txBox="1"/>
-          <p:nvPr/>
-        </p:nvSpPr>
-        <p:spPr>
-          <a:xfrm>
-            <a:off x="7818120" y="2331720"/>
-            <a:ext cx="3566160" cy="1188720"/>
+            <a:endParaRPr lang="en-US" sz="1500" dirty="0"/>
+          </a:p>
+        </p:txBody>
+      </p:sp>
+      <p:sp>
+        <p:nvSpPr>
+          <p:cNvPr id="8" name="Text 5"/>
+          <p:cNvSpPr txBox="1"/>
+          <p:nvPr/>
+        </p:nvSpPr>
+        <p:spPr>
+          <a:xfrm>
+            <a:off x="9235440" y="2286000"/>
+            <a:ext cx="2194560" cy="1188720"/>
           </a:xfrm>
           <a:prstGeom prst="rect">
             <a:avLst/>
@@ -10185,7 +9950,7 @@
               <a:buNone/>
             </a:pPr>
             <a:r>
-              <a:rPr lang="en-US" sz="1400" dirty="0">
+              <a:rPr lang="en-US" sz="1300" dirty="0">
                 <a:solidFill>
                   <a:srgbClr val="A5B4FC"/>
                 </a:solidFill>
@@ -10193,16 +9958,16 @@
                 <a:ea typeface="Calibri" pitchFamily="34" charset="-122"/>
                 <a:cs typeface="Calibri" pitchFamily="34" charset="-120"/>
               </a:rPr>
-              <a:t>complaints per 100k population</a:t>
-            </a:r>
-            <a:endParaRPr lang="en-US" sz="1400" dirty="0"/>
-          </a:p>
-          <a:p>
-            <a:pPr indent="0" marL="0">
-              <a:buNone/>
-            </a:pPr>
-            <a:r>
-              <a:rPr lang="en-US" sz="1400" dirty="0">
+              <a:t>complaints per 100k</a:t>
+            </a:r>
+            <a:endParaRPr lang="en-US" sz="1300" dirty="0"/>
+          </a:p>
+          <a:p>
+            <a:pPr indent="0" marL="0">
+              <a:buNone/>
+            </a:pPr>
+            <a:r>
+              <a:rPr lang="en-US" sz="1300" dirty="0">
                 <a:solidFill>
                   <a:srgbClr val="A5B4FC"/>
                 </a:solidFill>
@@ -10212,14 +9977,14 @@
               </a:rPr>
               <a:t>x mean urgency</a:t>
             </a:r>
-            <a:endParaRPr lang="en-US" sz="1400" dirty="0"/>
-          </a:p>
-          <a:p>
-            <a:pPr indent="0" marL="0">
-              <a:buNone/>
-            </a:pPr>
-            <a:r>
-              <a:rPr lang="en-US" sz="1400" dirty="0">
+            <a:endParaRPr lang="en-US" sz="1300" dirty="0"/>
+          </a:p>
+          <a:p>
+            <a:pPr indent="0" marL="0">
+              <a:buNone/>
+            </a:pPr>
+            <a:r>
+              <a:rPr lang="en-US" sz="1300" dirty="0">
                 <a:solidFill>
                   <a:srgbClr val="A5B4FC"/>
                 </a:solidFill>
@@ -10227,16 +9992,16 @@
                 <a:ea typeface="Calibri" pitchFamily="34" charset="-122"/>
                 <a:cs typeface="Calibri" pitchFamily="34" charset="-120"/>
               </a:rPr>
-              <a:t>x (1 + deprivation factor)</a:t>
-            </a:r>
-            <a:endParaRPr lang="en-US" sz="1400" dirty="0"/>
-          </a:p>
-          <a:p>
-            <a:pPr indent="0" marL="0">
-              <a:buNone/>
-            </a:pPr>
-            <a:r>
-              <a:rPr lang="en-US" sz="1400" dirty="0">
+              <a:t>x (1 + deprivation)</a:t>
+            </a:r>
+            <a:endParaRPr lang="en-US" sz="1300" dirty="0"/>
+          </a:p>
+          <a:p>
+            <a:pPr indent="0" marL="0">
+              <a:buNone/>
+            </a:pPr>
+            <a:r>
+              <a:rPr lang="en-US" sz="1300" dirty="0">
                 <a:solidFill>
                   <a:srgbClr val="A5B4FC"/>
                 </a:solidFill>
@@ -10244,38 +10009,38 @@
                 <a:ea typeface="Calibri" pitchFamily="34" charset="-122"/>
                 <a:cs typeface="Calibri" pitchFamily="34" charset="-120"/>
               </a:rPr>
-              <a:t>x unresolved-age factor</a:t>
-            </a:r>
-            <a:endParaRPr lang="en-US" sz="1400" dirty="0"/>
-          </a:p>
-        </p:txBody>
-      </p:sp>
-      <p:sp>
-        <p:nvSpPr>
-          <p:cNvPr id="8" name="Text 5"/>
-          <p:cNvSpPr txBox="1"/>
-          <p:nvPr/>
-        </p:nvSpPr>
-        <p:spPr>
-          <a:xfrm>
-            <a:off x="7818120" y="3520440"/>
-            <a:ext cx="3566160" cy="457200"/>
-          </a:xfrm>
-          <a:prstGeom prst="rect">
-            <a:avLst/>
-          </a:prstGeom>
-          <a:noFill/>
-          <a:ln/>
-        </p:spPr>
-        <p:txBody>
-          <a:bodyPr wrap="square" lIns="0" tIns="0" rIns="0" bIns="0" rtlCol="0" anchor="t"/>
-          <a:lstStyle/>
-          <a:p>
-            <a:pPr indent="0" marL="0">
-              <a:buNone/>
-            </a:pPr>
-            <a:r>
-              <a:rPr lang="en-US" sz="1100" dirty="0">
+              <a:t>x unresolved-age</a:t>
+            </a:r>
+            <a:endParaRPr lang="en-US" sz="1300" dirty="0"/>
+          </a:p>
+        </p:txBody>
+      </p:sp>
+      <p:sp>
+        <p:nvSpPr>
+          <p:cNvPr id="9" name="Text 6"/>
+          <p:cNvSpPr txBox="1"/>
+          <p:nvPr/>
+        </p:nvSpPr>
+        <p:spPr>
+          <a:xfrm>
+            <a:off x="9235440" y="3429000"/>
+            <a:ext cx="2194560" cy="274320"/>
+          </a:xfrm>
+          <a:prstGeom prst="rect">
+            <a:avLst/>
+          </a:prstGeom>
+          <a:noFill/>
+          <a:ln/>
+        </p:spPr>
+        <p:txBody>
+          <a:bodyPr wrap="square" lIns="0" tIns="0" rIns="0" bIns="0" rtlCol="0" anchor="ctr"/>
+          <a:lstStyle/>
+          <a:p>
+            <a:pPr indent="0" marL="0">
+              <a:buNone/>
+            </a:pPr>
+            <a:r>
+              <a:rPr lang="en-US" sz="1000" dirty="0">
                 <a:solidFill>
                   <a:srgbClr val="94A3B8"/>
                 </a:solidFill>
@@ -10283,26 +10048,26 @@
                 <a:ea typeface="Calibri" pitchFamily="34" charset="-122"/>
                 <a:cs typeface="Calibri" pitchFamily="34" charset="-120"/>
               </a:rPr>
-              <a:t>Weights live in lib/priority.ts and appear in the dashboard tooltip.</a:t>
-            </a:r>
-            <a:endParaRPr lang="en-US" sz="1100" dirty="0"/>
-          </a:p>
-        </p:txBody>
-      </p:sp>
-      <p:sp>
-        <p:nvSpPr>
-          <p:cNvPr id="9" name="Shape 6"/>
+              <a:t>Weights: lib/priority.ts</a:t>
+            </a:r>
+            <a:endParaRPr lang="en-US" sz="1000" dirty="0"/>
+          </a:p>
+        </p:txBody>
+      </p:sp>
+      <p:sp>
+        <p:nvSpPr>
+          <p:cNvPr id="10" name="Shape 7"/>
           <p:cNvSpPr/>
           <p:nvPr/>
         </p:nvSpPr>
         <p:spPr>
           <a:xfrm>
-            <a:off x="7589520" y="4297680"/>
-            <a:ext cx="3977640" cy="1691640"/>
+            <a:off x="9052560" y="4023360"/>
+            <a:ext cx="2514600" cy="1399032"/>
           </a:xfrm>
           <a:prstGeom prst="roundRect">
             <a:avLst>
-              <a:gd name="adj" fmla="val 6486"/>
+              <a:gd name="adj" fmla="val 7843"/>
             </a:avLst>
           </a:prstGeom>
           <a:solidFill>
@@ -10325,14 +10090,14 @@
       </p:sp>
       <p:sp>
         <p:nvSpPr>
-          <p:cNvPr id="10" name="Text 7"/>
-          <p:cNvSpPr txBox="1"/>
-          <p:nvPr/>
-        </p:nvSpPr>
-        <p:spPr>
-          <a:xfrm>
-            <a:off x="7818120" y="4407408"/>
-            <a:ext cx="3566160" cy="365760"/>
+          <p:cNvPr id="11" name="Text 8"/>
+          <p:cNvSpPr txBox="1"/>
+          <p:nvPr/>
+        </p:nvSpPr>
+        <p:spPr>
+          <a:xfrm>
+            <a:off x="9235440" y="4114800"/>
+            <a:ext cx="2194560" cy="320040"/>
           </a:xfrm>
           <a:prstGeom prst="rect">
             <a:avLst/>
@@ -10348,7 +10113,7 @@
               <a:buNone/>
             </a:pPr>
             <a:r>
-              <a:rPr lang="en-US" sz="1700" b="1" dirty="0">
+              <a:rPr lang="en-US" sz="1500" b="1" dirty="0">
                 <a:solidFill>
                   <a:srgbClr val="F59E0B"/>
                 </a:solidFill>
@@ -10358,20 +10123,20 @@
               </a:rPr>
               <a:t>Why it matters</a:t>
             </a:r>
-            <a:endParaRPr lang="en-US" sz="1700" dirty="0"/>
-          </a:p>
-        </p:txBody>
-      </p:sp>
-      <p:sp>
-        <p:nvSpPr>
-          <p:cNvPr id="11" name="Text 8"/>
-          <p:cNvSpPr txBox="1"/>
-          <p:nvPr/>
-        </p:nvSpPr>
-        <p:spPr>
-          <a:xfrm>
-            <a:off x="7818120" y="4800600"/>
-            <a:ext cx="3566160" cy="1097280"/>
+            <a:endParaRPr lang="en-US" sz="1500" dirty="0"/>
+          </a:p>
+        </p:txBody>
+      </p:sp>
+      <p:sp>
+        <p:nvSpPr>
+          <p:cNvPr id="12" name="Text 9"/>
+          <p:cNvSpPr txBox="1"/>
+          <p:nvPr/>
+        </p:nvSpPr>
+        <p:spPr>
+          <a:xfrm>
+            <a:off x="9235440" y="4462272"/>
+            <a:ext cx="2194560" cy="868680"/>
           </a:xfrm>
           <a:prstGeom prst="rect">
             <a:avLst/>
@@ -10387,7 +10152,7 @@
               <a:buNone/>
             </a:pPr>
             <a:r>
-              <a:rPr lang="en-US" sz="1300" dirty="0">
+              <a:rPr lang="en-US" sz="1200" dirty="0">
                 <a:solidFill>
                   <a:srgbClr val="E2E8F0"/>
                 </a:solidFill>
@@ -10395,7 +10160,46 @@
                 <a:ea typeface="Calibri" pitchFamily="34" charset="-122"/>
                 <a:cs typeface="Calibri" pitchFamily="34" charset="-120"/>
               </a:rPr>
-              <a:t>A small, under-served district with fewer reports can outrank a large city, because need is measured per head and adjusted for deprivation.</a:t>
+              <a:t>Small, aspirational districts rise because need is measured per head.</a:t>
+            </a:r>
+            <a:endParaRPr lang="en-US" sz="1200" dirty="0"/>
+          </a:p>
+        </p:txBody>
+      </p:sp>
+      <p:sp>
+        <p:nvSpPr>
+          <p:cNvPr id="13" name="Text 10"/>
+          <p:cNvSpPr txBox="1"/>
+          <p:nvPr/>
+        </p:nvSpPr>
+        <p:spPr>
+          <a:xfrm>
+            <a:off x="640080" y="5577840"/>
+            <a:ext cx="10881360" cy="640080"/>
+          </a:xfrm>
+          <a:prstGeom prst="rect">
+            <a:avLst/>
+          </a:prstGeom>
+          <a:noFill/>
+          <a:ln/>
+        </p:spPr>
+        <p:txBody>
+          <a:bodyPr wrap="square" lIns="0" tIns="0" rIns="0" bIns="0" rtlCol="0" anchor="t"/>
+          <a:lstStyle/>
+          <a:p>
+            <a:pPr indent="0" marL="0">
+              <a:buNone/>
+            </a:pPr>
+            <a:r>
+              <a:rPr lang="en-US" sz="1300" i="1" dirty="0">
+                <a:solidFill>
+                  <a:srgbClr val="A5B4FC"/>
+                </a:solidFill>
+                <a:latin typeface="Calibri" pitchFamily="34" charset="0"/>
+                <a:ea typeface="Calibri" pitchFamily="34" charset="-122"/>
+                <a:cs typeface="Calibri" pitchFamily="34" charset="-120"/>
+              </a:rPr>
+              <a:t>Honest note: in this demo every cluster has one complaint, so the raw rank is a tie-break. The re-ranking effect grows with real complaint volumes, which is what a pilot would measure.</a:t>
             </a:r>
             <a:endParaRPr lang="en-US" sz="1300" dirty="0"/>
           </a:p>
@@ -10403,7 +10207,7 @@
       </p:sp>
       <p:pic>
         <p:nvPicPr>
-          <p:cNvPr id="12" name="Image 0" descr="/tmp/deck/mark.png">    </p:cNvPr>
+          <p:cNvPr id="14" name="Image 1" descr="/tmp/deck/mark.png">    </p:cNvPr>
           <p:cNvPicPr>
             <a:picLocks noChangeAspect="1"/>
           </p:cNvPicPr>
@@ -10427,7 +10231,7 @@
       </p:pic>
       <p:sp>
         <p:nvSpPr>
-          <p:cNvPr id="13" name="Text 9"/>
+          <p:cNvPr id="15" name="Text 11"/>
           <p:cNvSpPr txBox="1"/>
           <p:nvPr/>
         </p:nvSpPr>
@@ -10466,7 +10270,7 @@
       </p:sp>
       <p:sp>
         <p:nvSpPr>
-          <p:cNvPr id="14" name="Text 10"/>
+          <p:cNvPr id="16" name="Text 12"/>
           <p:cNvSpPr txBox="1"/>
           <p:nvPr/>
         </p:nvSpPr>
@@ -10607,7 +10411,7 @@
                 <a:ea typeface="Calibri" pitchFamily="34" charset="-122"/>
                 <a:cs typeface="Calibri" pitchFamily="34" charset="-120"/>
               </a:rPr>
-              <a:t>Replace each frame with a screenshot from the live demo</a:t>
+              <a:t>Citizen side on a phone, policymaker side on the dashboard</a:t>
             </a:r>
             <a:endParaRPr lang="en-US" sz="1600" dirty="0"/>
           </a:p>
@@ -10621,45 +10425,50 @@
         </p:nvSpPr>
         <p:spPr>
           <a:xfrm>
-            <a:off x="640080" y="1874520"/>
-            <a:ext cx="2560320" cy="3429000"/>
+            <a:off x="640080" y="1783080"/>
+            <a:ext cx="2270821" cy="3675888"/>
           </a:xfrm>
           <a:prstGeom prst="roundRect">
             <a:avLst>
-              <a:gd name="adj" fmla="val 4286"/>
+              <a:gd name="adj" fmla="val 4027"/>
             </a:avLst>
           </a:prstGeom>
           <a:solidFill>
-            <a:srgbClr val="E0E7FF"/>
+            <a:srgbClr val="0F0F1A"/>
           </a:solidFill>
-          <a:ln w="12700">
+          <a:ln w="9525">
             <a:solidFill>
-              <a:srgbClr val="6366F1"/>
+              <a:srgbClr val="E2E8F0"/>
             </a:solidFill>
-            <a:prstDash val="dash"/>
+            <a:prstDash val="solid"/>
           </a:ln>
+          <a:effectLst>
+            <a:outerShdw sx="100000" sy="100000" kx="0" ky="0" algn="bl" rotWithShape="0" blurRad="101600" dist="25400" dir="5400000">
+              <a:srgbClr val="000000">
+                <a:alpha val="12000"/>
+              </a:srgbClr>
+            </a:outerShdw>
+          </a:effectLst>
         </p:spPr>
       </p:sp>
       <p:pic>
         <p:nvPicPr>
-          <p:cNvPr id="5" name="Image 0" descr="/tmp/deck/mark.png">    </p:cNvPr>
+          <p:cNvPr id="5" name="Image 0" descr="/tmp/deck/shots/form.png">    </p:cNvPr>
           <p:cNvPicPr>
             <a:picLocks noChangeAspect="1"/>
           </p:cNvPicPr>
           <p:nvPr/>
         </p:nvPicPr>
         <p:blipFill>
-          <a:blip r:embed="rId1">
-            <a:alphaModFix amt="45000"/>
-          </a:blip>
+          <a:blip r:embed="rId1"/>
           <a:stretch>
             <a:fillRect/>
           </a:stretch>
         </p:blipFill>
         <p:spPr>
           <a:xfrm>
-            <a:off x="1600200" y="3063240"/>
-            <a:ext cx="640080" cy="658368"/>
+            <a:off x="694944" y="1837944"/>
+            <a:ext cx="2161093" cy="3566160"/>
           </a:xfrm>
           <a:prstGeom prst="rect">
             <a:avLst/>
@@ -10668,168 +10477,56 @@
       </p:pic>
       <p:sp>
         <p:nvSpPr>
-          <p:cNvPr id="6" name="Text 3"/>
-          <p:cNvSpPr txBox="1"/>
-          <p:nvPr/>
-        </p:nvSpPr>
-        <p:spPr>
-          <a:xfrm>
-            <a:off x="640080" y="3794760"/>
-            <a:ext cx="2560320" cy="274320"/>
-          </a:xfrm>
-          <a:prstGeom prst="rect">
-            <a:avLst/>
-          </a:prstGeom>
-          <a:noFill/>
-          <a:ln/>
-        </p:spPr>
-        <p:txBody>
-          <a:bodyPr wrap="square" lIns="0" tIns="0" rIns="0" bIns="0" rtlCol="0" anchor="ctr"/>
-          <a:lstStyle/>
-          <a:p>
-            <a:pPr algn="ctr" indent="0" marL="0">
-              <a:buNone/>
-            </a:pPr>
-            <a:r>
-              <a:rPr lang="en-US" sz="1100" dirty="0">
-                <a:solidFill>
-                  <a:srgbClr val="6366F1"/>
-                </a:solidFill>
-                <a:latin typeface="Calibri" pitchFamily="34" charset="0"/>
-                <a:ea typeface="Calibri" pitchFamily="34" charset="-122"/>
-                <a:cs typeface="Calibri" pitchFamily="34" charset="-120"/>
-              </a:rPr>
-              <a:t>Screenshot</a:t>
-            </a:r>
-            <a:endParaRPr lang="en-US" sz="1100" dirty="0"/>
-          </a:p>
-        </p:txBody>
-      </p:sp>
-      <p:sp>
-        <p:nvSpPr>
-          <p:cNvPr id="7" name="Text 4"/>
-          <p:cNvSpPr txBox="1"/>
-          <p:nvPr/>
-        </p:nvSpPr>
-        <p:spPr>
-          <a:xfrm>
-            <a:off x="640080" y="5440680"/>
-            <a:ext cx="2560320" cy="365760"/>
-          </a:xfrm>
-          <a:prstGeom prst="rect">
-            <a:avLst/>
-          </a:prstGeom>
-          <a:noFill/>
-          <a:ln/>
-        </p:spPr>
-        <p:txBody>
-          <a:bodyPr wrap="square" lIns="0" tIns="0" rIns="0" bIns="0" rtlCol="0" anchor="ctr"/>
-          <a:lstStyle/>
-          <a:p>
-            <a:pPr indent="0" marL="0">
-              <a:buNone/>
-            </a:pPr>
-            <a:r>
-              <a:rPr lang="en-US" sz="1600" b="1" dirty="0">
-                <a:solidFill>
-                  <a:srgbClr val="0F172A"/>
-                </a:solidFill>
-                <a:latin typeface="Calibri" pitchFamily="34" charset="0"/>
-                <a:ea typeface="Calibri" pitchFamily="34" charset="-122"/>
-                <a:cs typeface="Calibri" pitchFamily="34" charset="-120"/>
-              </a:rPr>
-              <a:t>Citizen portal</a:t>
-            </a:r>
-            <a:endParaRPr lang="en-US" sz="1600" dirty="0"/>
-          </a:p>
-        </p:txBody>
-      </p:sp>
-      <p:sp>
-        <p:nvSpPr>
-          <p:cNvPr id="8" name="Text 5"/>
-          <p:cNvSpPr txBox="1"/>
-          <p:nvPr/>
-        </p:nvSpPr>
-        <p:spPr>
-          <a:xfrm>
-            <a:off x="640080" y="5779008"/>
-            <a:ext cx="2560320" cy="457200"/>
-          </a:xfrm>
-          <a:prstGeom prst="rect">
-            <a:avLst/>
-          </a:prstGeom>
-          <a:noFill/>
-          <a:ln/>
-        </p:spPr>
-        <p:txBody>
-          <a:bodyPr wrap="square" lIns="0" tIns="0" rIns="0" bIns="0" rtlCol="0" anchor="t"/>
-          <a:lstStyle/>
-          <a:p>
-            <a:pPr indent="0" marL="0">
-              <a:buNone/>
-            </a:pPr>
-            <a:r>
-              <a:rPr lang="en-US" sz="1200" dirty="0">
-                <a:solidFill>
-                  <a:srgbClr val="64748B"/>
-                </a:solidFill>
-                <a:latin typeface="Calibri" pitchFamily="34" charset="0"/>
-                <a:ea typeface="Calibri" pitchFamily="34" charset="-122"/>
-                <a:cs typeface="Calibri" pitchFamily="34" charset="-120"/>
-              </a:rPr>
-              <a:t>Report in your language, by voice, text or photo</a:t>
-            </a:r>
-            <a:endParaRPr lang="en-US" sz="1200" dirty="0"/>
-          </a:p>
-        </p:txBody>
-      </p:sp>
-      <p:sp>
-        <p:nvSpPr>
-          <p:cNvPr id="9" name="Shape 6"/>
+          <p:cNvPr id="6" name="Shape 3"/>
           <p:cNvSpPr/>
           <p:nvPr/>
         </p:nvSpPr>
         <p:spPr>
           <a:xfrm>
-            <a:off x="3456432" y="1874520"/>
-            <a:ext cx="2560320" cy="3429000"/>
+            <a:off x="3166933" y="1783080"/>
+            <a:ext cx="2270821" cy="3675888"/>
           </a:xfrm>
           <a:prstGeom prst="roundRect">
             <a:avLst>
-              <a:gd name="adj" fmla="val 4286"/>
+              <a:gd name="adj" fmla="val 4027"/>
             </a:avLst>
           </a:prstGeom>
           <a:solidFill>
-            <a:srgbClr val="E0E7FF"/>
+            <a:srgbClr val="0F0F1A"/>
           </a:solidFill>
-          <a:ln w="12700">
+          <a:ln w="9525">
             <a:solidFill>
-              <a:srgbClr val="6366F1"/>
+              <a:srgbClr val="E2E8F0"/>
             </a:solidFill>
-            <a:prstDash val="dash"/>
+            <a:prstDash val="solid"/>
           </a:ln>
+          <a:effectLst>
+            <a:outerShdw sx="100000" sy="100000" kx="0" ky="0" algn="bl" rotWithShape="0" blurRad="101600" dist="25400" dir="5400000">
+              <a:srgbClr val="000000">
+                <a:alpha val="12000"/>
+              </a:srgbClr>
+            </a:outerShdw>
+          </a:effectLst>
         </p:spPr>
       </p:sp>
       <p:pic>
         <p:nvPicPr>
-          <p:cNvPr id="10" name="Image 1" descr="/tmp/deck/mark.png">    </p:cNvPr>
+          <p:cNvPr id="7" name="Image 1" descr="/tmp/deck/shots/submitted.png">    </p:cNvPr>
           <p:cNvPicPr>
             <a:picLocks noChangeAspect="1"/>
           </p:cNvPicPr>
           <p:nvPr/>
         </p:nvPicPr>
         <p:blipFill>
-          <a:blip r:embed="rId2">
-            <a:alphaModFix amt="45000"/>
-          </a:blip>
+          <a:blip r:embed="rId2"/>
           <a:stretch>
             <a:fillRect/>
           </a:stretch>
         </p:blipFill>
         <p:spPr>
           <a:xfrm>
-            <a:off x="4416552" y="3063240"/>
-            <a:ext cx="640080" cy="658368"/>
+            <a:off x="3221797" y="1837944"/>
+            <a:ext cx="2161093" cy="3566160"/>
           </a:xfrm>
           <a:prstGeom prst="rect">
             <a:avLst/>
@@ -10838,14 +10535,131 @@
       </p:pic>
       <p:sp>
         <p:nvSpPr>
+          <p:cNvPr id="8" name="Text 4"/>
+          <p:cNvSpPr txBox="1"/>
+          <p:nvPr/>
+        </p:nvSpPr>
+        <p:spPr>
+          <a:xfrm>
+            <a:off x="640080" y="5532120"/>
+            <a:ext cx="2526853" cy="274320"/>
+          </a:xfrm>
+          <a:prstGeom prst="rect">
+            <a:avLst/>
+          </a:prstGeom>
+          <a:noFill/>
+          <a:ln/>
+        </p:spPr>
+        <p:txBody>
+          <a:bodyPr wrap="square" lIns="0" tIns="0" rIns="0" bIns="0" rtlCol="0" anchor="ctr"/>
+          <a:lstStyle/>
+          <a:p>
+            <a:pPr indent="0" marL="0">
+              <a:buNone/>
+            </a:pPr>
+            <a:r>
+              <a:rPr lang="en-US" sz="1400" b="1" dirty="0">
+                <a:solidFill>
+                  <a:srgbClr val="0F172A"/>
+                </a:solidFill>
+                <a:latin typeface="Calibri" pitchFamily="34" charset="0"/>
+                <a:ea typeface="Calibri" pitchFamily="34" charset="-122"/>
+                <a:cs typeface="Calibri" pitchFamily="34" charset="-120"/>
+              </a:rPr>
+              <a:t>Report in your language</a:t>
+            </a:r>
+            <a:endParaRPr lang="en-US" sz="1400" dirty="0"/>
+          </a:p>
+        </p:txBody>
+      </p:sp>
+      <p:sp>
+        <p:nvSpPr>
+          <p:cNvPr id="9" name="Text 5"/>
+          <p:cNvSpPr txBox="1"/>
+          <p:nvPr/>
+        </p:nvSpPr>
+        <p:spPr>
+          <a:xfrm>
+            <a:off x="640080" y="5806440"/>
+            <a:ext cx="2526853" cy="274320"/>
+          </a:xfrm>
+          <a:prstGeom prst="rect">
+            <a:avLst/>
+          </a:prstGeom>
+          <a:noFill/>
+          <a:ln/>
+        </p:spPr>
+        <p:txBody>
+          <a:bodyPr wrap="square" lIns="0" tIns="0" rIns="0" bIns="0" rtlCol="0" anchor="ctr"/>
+          <a:lstStyle/>
+          <a:p>
+            <a:pPr indent="0" marL="0">
+              <a:buNone/>
+            </a:pPr>
+            <a:r>
+              <a:rPr lang="en-US" sz="1100" dirty="0">
+                <a:solidFill>
+                  <a:srgbClr val="64748B"/>
+                </a:solidFill>
+                <a:latin typeface="Calibri" pitchFamily="34" charset="0"/>
+                <a:ea typeface="Calibri" pitchFamily="34" charset="-122"/>
+                <a:cs typeface="Calibri" pitchFamily="34" charset="-120"/>
+              </a:rPr>
+              <a:t>Quick or detailed form with a map pin</a:t>
+            </a:r>
+            <a:endParaRPr lang="en-US" sz="1100" dirty="0"/>
+          </a:p>
+        </p:txBody>
+      </p:sp>
+      <p:sp>
+        <p:nvSpPr>
+          <p:cNvPr id="10" name="Text 6"/>
+          <p:cNvSpPr txBox="1"/>
+          <p:nvPr/>
+        </p:nvSpPr>
+        <p:spPr>
+          <a:xfrm>
+            <a:off x="3166933" y="5532120"/>
+            <a:ext cx="2526853" cy="274320"/>
+          </a:xfrm>
+          <a:prstGeom prst="rect">
+            <a:avLst/>
+          </a:prstGeom>
+          <a:noFill/>
+          <a:ln/>
+        </p:spPr>
+        <p:txBody>
+          <a:bodyPr wrap="square" lIns="0" tIns="0" rIns="0" bIns="0" rtlCol="0" anchor="ctr"/>
+          <a:lstStyle/>
+          <a:p>
+            <a:pPr indent="0" marL="0">
+              <a:buNone/>
+            </a:pPr>
+            <a:r>
+              <a:rPr lang="en-US" sz="1400" b="1" dirty="0">
+                <a:solidFill>
+                  <a:srgbClr val="0F172A"/>
+                </a:solidFill>
+                <a:latin typeface="Calibri" pitchFamily="34" charset="0"/>
+                <a:ea typeface="Calibri" pitchFamily="34" charset="-122"/>
+                <a:cs typeface="Calibri" pitchFamily="34" charset="-120"/>
+              </a:rPr>
+              <a:t>Tracking reference</a:t>
+            </a:r>
+            <a:endParaRPr lang="en-US" sz="1400" dirty="0"/>
+          </a:p>
+        </p:txBody>
+      </p:sp>
+      <p:sp>
+        <p:nvSpPr>
           <p:cNvPr id="11" name="Text 7"/>
           <p:cNvSpPr txBox="1"/>
           <p:nvPr/>
         </p:nvSpPr>
         <p:spPr>
           <a:xfrm>
-            <a:off x="3456432" y="3794760"/>
-            <a:ext cx="2560320" cy="274320"/>
+            <a:off x="3166933" y="5806440"/>
+            <a:ext cx="2526853" cy="274320"/>
           </a:xfrm>
           <a:prstGeom prst="rect">
             <a:avLst/>
@@ -10857,19 +10671,19 @@
           <a:bodyPr wrap="square" lIns="0" tIns="0" rIns="0" bIns="0" rtlCol="0" anchor="ctr"/>
           <a:lstStyle/>
           <a:p>
-            <a:pPr algn="ctr" indent="0" marL="0">
+            <a:pPr indent="0" marL="0">
               <a:buNone/>
             </a:pPr>
             <a:r>
               <a:rPr lang="en-US" sz="1100" dirty="0">
                 <a:solidFill>
-                  <a:srgbClr val="6366F1"/>
-                </a:solidFill>
-                <a:latin typeface="Calibri" pitchFamily="34" charset="0"/>
-                <a:ea typeface="Calibri" pitchFamily="34" charset="-122"/>
-                <a:cs typeface="Calibri" pitchFamily="34" charset="-120"/>
-              </a:rPr>
-              <a:t>Screenshot</a:t>
+                  <a:srgbClr val="64748B"/>
+                </a:solidFill>
+                <a:latin typeface="Calibri" pitchFamily="34" charset="0"/>
+                <a:ea typeface="Calibri" pitchFamily="34" charset="-122"/>
+                <a:cs typeface="Calibri" pitchFamily="34" charset="-120"/>
+              </a:rPr>
+              <a:t>Citizens follow status by ID</a:t>
             </a:r>
             <a:endParaRPr lang="en-US" sz="1100" dirty="0"/>
           </a:p>
@@ -10877,129 +10691,56 @@
       </p:sp>
       <p:sp>
         <p:nvSpPr>
-          <p:cNvPr id="12" name="Text 8"/>
-          <p:cNvSpPr txBox="1"/>
-          <p:nvPr/>
-        </p:nvSpPr>
-        <p:spPr>
-          <a:xfrm>
-            <a:off x="3456432" y="5440680"/>
-            <a:ext cx="2560320" cy="365760"/>
-          </a:xfrm>
-          <a:prstGeom prst="rect">
-            <a:avLst/>
-          </a:prstGeom>
-          <a:noFill/>
-          <a:ln/>
-        </p:spPr>
-        <p:txBody>
-          <a:bodyPr wrap="square" lIns="0" tIns="0" rIns="0" bIns="0" rtlCol="0" anchor="ctr"/>
-          <a:lstStyle/>
-          <a:p>
-            <a:pPr indent="0" marL="0">
-              <a:buNone/>
-            </a:pPr>
-            <a:r>
-              <a:rPr lang="en-US" sz="1600" b="1" dirty="0">
-                <a:solidFill>
-                  <a:srgbClr val="0F172A"/>
-                </a:solidFill>
-                <a:latin typeface="Calibri" pitchFamily="34" charset="0"/>
-                <a:ea typeface="Calibri" pitchFamily="34" charset="-122"/>
-                <a:cs typeface="Calibri" pitchFamily="34" charset="-120"/>
-              </a:rPr>
-              <a:t>Tracking</a:t>
-            </a:r>
-            <a:endParaRPr lang="en-US" sz="1600" dirty="0"/>
-          </a:p>
-        </p:txBody>
-      </p:sp>
-      <p:sp>
-        <p:nvSpPr>
-          <p:cNvPr id="13" name="Text 9"/>
-          <p:cNvSpPr txBox="1"/>
-          <p:nvPr/>
-        </p:nvSpPr>
-        <p:spPr>
-          <a:xfrm>
-            <a:off x="3456432" y="5779008"/>
-            <a:ext cx="2560320" cy="457200"/>
-          </a:xfrm>
-          <a:prstGeom prst="rect">
-            <a:avLst/>
-          </a:prstGeom>
-          <a:noFill/>
-          <a:ln/>
-        </p:spPr>
-        <p:txBody>
-          <a:bodyPr wrap="square" lIns="0" tIns="0" rIns="0" bIns="0" rtlCol="0" anchor="t"/>
-          <a:lstStyle/>
-          <a:p>
-            <a:pPr indent="0" marL="0">
-              <a:buNone/>
-            </a:pPr>
-            <a:r>
-              <a:rPr lang="en-US" sz="1200" dirty="0">
-                <a:solidFill>
-                  <a:srgbClr val="64748B"/>
-                </a:solidFill>
-                <a:latin typeface="Calibri" pitchFamily="34" charset="0"/>
-                <a:ea typeface="Calibri" pitchFamily="34" charset="-122"/>
-                <a:cs typeface="Calibri" pitchFamily="34" charset="-120"/>
-              </a:rPr>
-              <a:t>Follow status with a tracking ID</a:t>
-            </a:r>
-            <a:endParaRPr lang="en-US" sz="1200" dirty="0"/>
-          </a:p>
-        </p:txBody>
-      </p:sp>
-      <p:sp>
-        <p:nvSpPr>
-          <p:cNvPr id="14" name="Shape 10"/>
+          <p:cNvPr id="12" name="Shape 8"/>
           <p:cNvSpPr/>
           <p:nvPr/>
         </p:nvSpPr>
         <p:spPr>
           <a:xfrm>
-            <a:off x="6272784" y="1874520"/>
-            <a:ext cx="2560320" cy="3429000"/>
+            <a:off x="6126480" y="1783080"/>
+            <a:ext cx="5394960" cy="1861338"/>
           </a:xfrm>
           <a:prstGeom prst="roundRect">
             <a:avLst>
-              <a:gd name="adj" fmla="val 4286"/>
+              <a:gd name="adj" fmla="val 4913"/>
             </a:avLst>
           </a:prstGeom>
           <a:solidFill>
-            <a:srgbClr val="E0E7FF"/>
+            <a:srgbClr val="0F0F1A"/>
           </a:solidFill>
-          <a:ln w="12700">
+          <a:ln w="9525">
             <a:solidFill>
-              <a:srgbClr val="6366F1"/>
+              <a:srgbClr val="E2E8F0"/>
             </a:solidFill>
-            <a:prstDash val="dash"/>
+            <a:prstDash val="solid"/>
           </a:ln>
+          <a:effectLst>
+            <a:outerShdw sx="100000" sy="100000" kx="0" ky="0" algn="bl" rotWithShape="0" blurRad="101600" dist="25400" dir="5400000">
+              <a:srgbClr val="000000">
+                <a:alpha val="12000"/>
+              </a:srgbClr>
+            </a:outerShdw>
+          </a:effectLst>
         </p:spPr>
       </p:sp>
       <p:pic>
         <p:nvPicPr>
-          <p:cNvPr id="15" name="Image 2" descr="/tmp/deck/mark.png">    </p:cNvPr>
+          <p:cNvPr id="13" name="Image 2" descr="/tmp/deck/shots/heatmap-map.png">    </p:cNvPr>
           <p:cNvPicPr>
             <a:picLocks noChangeAspect="1"/>
           </p:cNvPicPr>
           <p:nvPr/>
         </p:nvPicPr>
         <p:blipFill>
-          <a:blip r:embed="rId3">
-            <a:alphaModFix amt="45000"/>
-          </a:blip>
+          <a:blip r:embed="rId3"/>
           <a:stretch>
             <a:fillRect/>
           </a:stretch>
         </p:blipFill>
         <p:spPr>
           <a:xfrm>
-            <a:off x="7232904" y="3063240"/>
-            <a:ext cx="640080" cy="658368"/>
+            <a:off x="6181344" y="1837944"/>
+            <a:ext cx="5285232" cy="1751610"/>
           </a:xfrm>
           <a:prstGeom prst="rect">
             <a:avLst/>
@@ -11008,14 +10749,14 @@
       </p:pic>
       <p:sp>
         <p:nvSpPr>
-          <p:cNvPr id="16" name="Text 11"/>
-          <p:cNvSpPr txBox="1"/>
-          <p:nvPr/>
-        </p:nvSpPr>
-        <p:spPr>
-          <a:xfrm>
-            <a:off x="6272784" y="3794760"/>
-            <a:ext cx="2560320" cy="274320"/>
+          <p:cNvPr id="14" name="Text 9"/>
+          <p:cNvSpPr txBox="1"/>
+          <p:nvPr/>
+        </p:nvSpPr>
+        <p:spPr>
+          <a:xfrm>
+            <a:off x="6126480" y="3717570"/>
+            <a:ext cx="5394960" cy="274320"/>
           </a:xfrm>
           <a:prstGeom prst="rect">
             <a:avLst/>
@@ -11027,50 +10768,11 @@
           <a:bodyPr wrap="square" lIns="0" tIns="0" rIns="0" bIns="0" rtlCol="0" anchor="ctr"/>
           <a:lstStyle/>
           <a:p>
-            <a:pPr algn="ctr" indent="0" marL="0">
-              <a:buNone/>
-            </a:pPr>
-            <a:r>
-              <a:rPr lang="en-US" sz="1100" dirty="0">
-                <a:solidFill>
-                  <a:srgbClr val="6366F1"/>
-                </a:solidFill>
-                <a:latin typeface="Calibri" pitchFamily="34" charset="0"/>
-                <a:ea typeface="Calibri" pitchFamily="34" charset="-122"/>
-                <a:cs typeface="Calibri" pitchFamily="34" charset="-120"/>
-              </a:rPr>
-              <a:t>Screenshot</a:t>
-            </a:r>
-            <a:endParaRPr lang="en-US" sz="1100" dirty="0"/>
-          </a:p>
-        </p:txBody>
-      </p:sp>
-      <p:sp>
-        <p:nvSpPr>
-          <p:cNvPr id="17" name="Text 12"/>
-          <p:cNvSpPr txBox="1"/>
-          <p:nvPr/>
-        </p:nvSpPr>
-        <p:spPr>
-          <a:xfrm>
-            <a:off x="6272784" y="5440680"/>
-            <a:ext cx="2560320" cy="365760"/>
-          </a:xfrm>
-          <a:prstGeom prst="rect">
-            <a:avLst/>
-          </a:prstGeom>
-          <a:noFill/>
-          <a:ln/>
-        </p:spPr>
-        <p:txBody>
-          <a:bodyPr wrap="square" lIns="0" tIns="0" rIns="0" bIns="0" rtlCol="0" anchor="ctr"/>
-          <a:lstStyle/>
-          <a:p>
-            <a:pPr indent="0" marL="0">
-              <a:buNone/>
-            </a:pPr>
-            <a:r>
-              <a:rPr lang="en-US" sz="1600" b="1" dirty="0">
+            <a:pPr indent="0" marL="0">
+              <a:buNone/>
+            </a:pPr>
+            <a:r>
+              <a:rPr lang="en-US" sz="1400" b="1" dirty="0">
                 <a:solidFill>
                   <a:srgbClr val="0F172A"/>
                 </a:solidFill>
@@ -11078,98 +10780,64 @@
                 <a:ea typeface="Calibri" pitchFamily="34" charset="-122"/>
                 <a:cs typeface="Calibri" pitchFamily="34" charset="-120"/>
               </a:rPr>
-              <a:t>Demand heatmap</a:t>
-            </a:r>
-            <a:endParaRPr lang="en-US" sz="1600" dirty="0"/>
-          </a:p>
-        </p:txBody>
-      </p:sp>
-      <p:sp>
-        <p:nvSpPr>
-          <p:cNvPr id="18" name="Text 13"/>
-          <p:cNvSpPr txBox="1"/>
-          <p:nvPr/>
-        </p:nvSpPr>
-        <p:spPr>
-          <a:xfrm>
-            <a:off x="6272784" y="5779008"/>
-            <a:ext cx="2560320" cy="457200"/>
-          </a:xfrm>
-          <a:prstGeom prst="rect">
-            <a:avLst/>
-          </a:prstGeom>
-          <a:noFill/>
-          <a:ln/>
-        </p:spPr>
-        <p:txBody>
-          <a:bodyPr wrap="square" lIns="0" tIns="0" rIns="0" bIns="0" rtlCol="0" anchor="t"/>
-          <a:lstStyle/>
-          <a:p>
-            <a:pPr indent="0" marL="0">
-              <a:buNone/>
-            </a:pPr>
-            <a:r>
-              <a:rPr lang="en-US" sz="1200" dirty="0">
-                <a:solidFill>
-                  <a:srgbClr val="64748B"/>
-                </a:solidFill>
-                <a:latin typeface="Calibri" pitchFamily="34" charset="0"/>
-                <a:ea typeface="Calibri" pitchFamily="34" charset="-122"/>
-                <a:cs typeface="Calibri" pitchFamily="34" charset="-120"/>
-              </a:rPr>
-              <a:t>Hotspots across states, by category</a:t>
-            </a:r>
-            <a:endParaRPr lang="en-US" sz="1200" dirty="0"/>
-          </a:p>
-        </p:txBody>
-      </p:sp>
-      <p:sp>
-        <p:nvSpPr>
-          <p:cNvPr id="19" name="Shape 14"/>
+              <a:t>Demand heatmap: hotspots by category</a:t>
+            </a:r>
+            <a:endParaRPr lang="en-US" sz="1400" dirty="0"/>
+          </a:p>
+        </p:txBody>
+      </p:sp>
+      <p:sp>
+        <p:nvSpPr>
+          <p:cNvPr id="15" name="Shape 10"/>
           <p:cNvSpPr/>
           <p:nvPr/>
         </p:nvSpPr>
         <p:spPr>
           <a:xfrm>
-            <a:off x="9089136" y="1874520"/>
-            <a:ext cx="2560320" cy="3429000"/>
+            <a:off x="6126480" y="4156482"/>
+            <a:ext cx="5394960" cy="1833357"/>
           </a:xfrm>
           <a:prstGeom prst="roundRect">
             <a:avLst>
-              <a:gd name="adj" fmla="val 4286"/>
+              <a:gd name="adj" fmla="val 4988"/>
             </a:avLst>
           </a:prstGeom>
           <a:solidFill>
-            <a:srgbClr val="E0E7FF"/>
+            <a:srgbClr val="0F0F1A"/>
           </a:solidFill>
-          <a:ln w="12700">
+          <a:ln w="9525">
             <a:solidFill>
-              <a:srgbClr val="6366F1"/>
+              <a:srgbClr val="E2E8F0"/>
             </a:solidFill>
-            <a:prstDash val="dash"/>
+            <a:prstDash val="solid"/>
           </a:ln>
+          <a:effectLst>
+            <a:outerShdw sx="100000" sy="100000" kx="0" ky="0" algn="bl" rotWithShape="0" blurRad="101600" dist="25400" dir="5400000">
+              <a:srgbClr val="000000">
+                <a:alpha val="12000"/>
+              </a:srgbClr>
+            </a:outerShdw>
+          </a:effectLst>
         </p:spPr>
       </p:sp>
       <p:pic>
         <p:nvPicPr>
-          <p:cNvPr id="20" name="Image 3" descr="/tmp/deck/mark.png">    </p:cNvPr>
+          <p:cNvPr id="16" name="Image 3" descr="/tmp/deck/shots/dept-top.png">    </p:cNvPr>
           <p:cNvPicPr>
             <a:picLocks noChangeAspect="1"/>
           </p:cNvPicPr>
           <p:nvPr/>
         </p:nvPicPr>
         <p:blipFill>
-          <a:blip r:embed="rId4">
-            <a:alphaModFix amt="45000"/>
-          </a:blip>
+          <a:blip r:embed="rId4"/>
           <a:stretch>
             <a:fillRect/>
           </a:stretch>
         </p:blipFill>
         <p:spPr>
           <a:xfrm>
-            <a:off x="10049256" y="3063240"/>
-            <a:ext cx="640080" cy="658368"/>
+            <a:off x="6181344" y="4211346"/>
+            <a:ext cx="5285232" cy="1723629"/>
           </a:xfrm>
           <a:prstGeom prst="rect">
             <a:avLst/>
@@ -11178,14 +10846,14 @@
       </p:pic>
       <p:sp>
         <p:nvSpPr>
-          <p:cNvPr id="21" name="Text 15"/>
-          <p:cNvSpPr txBox="1"/>
-          <p:nvPr/>
-        </p:nvSpPr>
-        <p:spPr>
-          <a:xfrm>
-            <a:off x="9089136" y="3794760"/>
-            <a:ext cx="2560320" cy="274320"/>
+          <p:cNvPr id="17" name="Text 11"/>
+          <p:cNvSpPr txBox="1"/>
+          <p:nvPr/>
+        </p:nvSpPr>
+        <p:spPr>
+          <a:xfrm>
+            <a:off x="6126480" y="6026416"/>
+            <a:ext cx="5394960" cy="274320"/>
           </a:xfrm>
           <a:prstGeom prst="rect">
             <a:avLst/>
@@ -11197,50 +10865,11 @@
           <a:bodyPr wrap="square" lIns="0" tIns="0" rIns="0" bIns="0" rtlCol="0" anchor="ctr"/>
           <a:lstStyle/>
           <a:p>
-            <a:pPr algn="ctr" indent="0" marL="0">
-              <a:buNone/>
-            </a:pPr>
-            <a:r>
-              <a:rPr lang="en-US" sz="1100" dirty="0">
-                <a:solidFill>
-                  <a:srgbClr val="6366F1"/>
-                </a:solidFill>
-                <a:latin typeface="Calibri" pitchFamily="34" charset="0"/>
-                <a:ea typeface="Calibri" pitchFamily="34" charset="-122"/>
-                <a:cs typeface="Calibri" pitchFamily="34" charset="-120"/>
-              </a:rPr>
-              <a:t>Screenshot</a:t>
-            </a:r>
-            <a:endParaRPr lang="en-US" sz="1100" dirty="0"/>
-          </a:p>
-        </p:txBody>
-      </p:sp>
-      <p:sp>
-        <p:nvSpPr>
-          <p:cNvPr id="22" name="Text 16"/>
-          <p:cNvSpPr txBox="1"/>
-          <p:nvPr/>
-        </p:nvSpPr>
-        <p:spPr>
-          <a:xfrm>
-            <a:off x="9089136" y="5440680"/>
-            <a:ext cx="2560320" cy="365760"/>
-          </a:xfrm>
-          <a:prstGeom prst="rect">
-            <a:avLst/>
-          </a:prstGeom>
-          <a:noFill/>
-          <a:ln/>
-        </p:spPr>
-        <p:txBody>
-          <a:bodyPr wrap="square" lIns="0" tIns="0" rIns="0" bIns="0" rtlCol="0" anchor="ctr"/>
-          <a:lstStyle/>
-          <a:p>
-            <a:pPr indent="0" marL="0">
-              <a:buNone/>
-            </a:pPr>
-            <a:r>
-              <a:rPr lang="en-US" sz="1600" b="1" dirty="0">
+            <a:pPr indent="0" marL="0">
+              <a:buNone/>
+            </a:pPr>
+            <a:r>
+              <a:rPr lang="en-US" sz="1400" b="1" dirty="0">
                 <a:solidFill>
                   <a:srgbClr val="0F172A"/>
                 </a:solidFill>
@@ -11248,54 +10877,15 @@
                 <a:ea typeface="Calibri" pitchFamily="34" charset="-122"/>
                 <a:cs typeface="Calibri" pitchFamily="34" charset="-120"/>
               </a:rPr>
-              <a:t>Priority rankings</a:t>
-            </a:r>
-            <a:endParaRPr lang="en-US" sz="1600" dirty="0"/>
-          </a:p>
-        </p:txBody>
-      </p:sp>
-      <p:sp>
-        <p:nvSpPr>
-          <p:cNvPr id="23" name="Text 17"/>
-          <p:cNvSpPr txBox="1"/>
-          <p:nvPr/>
-        </p:nvSpPr>
-        <p:spPr>
-          <a:xfrm>
-            <a:off x="9089136" y="5779008"/>
-            <a:ext cx="2560320" cy="457200"/>
-          </a:xfrm>
-          <a:prstGeom prst="rect">
-            <a:avLst/>
-          </a:prstGeom>
-          <a:noFill/>
-          <a:ln/>
-        </p:spPr>
-        <p:txBody>
-          <a:bodyPr wrap="square" lIns="0" tIns="0" rIns="0" bIns="0" rtlCol="0" anchor="t"/>
-          <a:lstStyle/>
-          <a:p>
-            <a:pPr indent="0" marL="0">
-              <a:buNone/>
-            </a:pPr>
-            <a:r>
-              <a:rPr lang="en-US" sz="1200" dirty="0">
-                <a:solidFill>
-                  <a:srgbClr val="64748B"/>
-                </a:solidFill>
-                <a:latin typeface="Calibri" pitchFamily="34" charset="0"/>
-                <a:ea typeface="Calibri" pitchFamily="34" charset="-122"/>
-                <a:cs typeface="Calibri" pitchFamily="34" charset="-120"/>
-              </a:rPr>
-              <a:t>Raw rank versus need-weighted rank</a:t>
-            </a:r>
-            <a:endParaRPr lang="en-US" sz="1200" dirty="0"/>
+              <a:t>Department SLA centre: AI auto-routing</a:t>
+            </a:r>
+            <a:endParaRPr lang="en-US" sz="1400" dirty="0"/>
           </a:p>
         </p:txBody>
       </p:sp>
       <p:pic>
         <p:nvPicPr>
-          <p:cNvPr id="24" name="Image 4" descr="/tmp/deck/mark.png">    </p:cNvPr>
+          <p:cNvPr id="18" name="Image 4" descr="/tmp/deck/mark.png">    </p:cNvPr>
           <p:cNvPicPr>
             <a:picLocks noChangeAspect="1"/>
           </p:cNvPicPr>
@@ -11319,7 +10909,7 @@
       </p:pic>
       <p:sp>
         <p:nvSpPr>
-          <p:cNvPr id="25" name="Text 18"/>
+          <p:cNvPr id="19" name="Text 12"/>
           <p:cNvSpPr txBox="1"/>
           <p:nvPr/>
         </p:nvSpPr>
@@ -11358,7 +10948,7 @@
       </p:sp>
       <p:sp>
         <p:nvSpPr>
-          <p:cNvPr id="26" name="Text 19"/>
+          <p:cNvPr id="20" name="Text 13"/>
           <p:cNvSpPr txBox="1"/>
           <p:nvPr/>
         </p:nvSpPr>
@@ -11513,12 +11103,12 @@
         </p:nvSpPr>
         <p:spPr>
           <a:xfrm>
-            <a:off x="640080" y="1874520"/>
-            <a:ext cx="3108960" cy="1783080"/>
+            <a:off x="640080" y="1783080"/>
+            <a:ext cx="2560320" cy="1371600"/>
           </a:xfrm>
           <a:prstGeom prst="roundRect">
             <a:avLst>
-              <a:gd name="adj" fmla="val 6154"/>
+              <a:gd name="adj" fmla="val 8000"/>
             </a:avLst>
           </a:prstGeom>
           <a:solidFill>
@@ -11547,8 +11137,8 @@
         </p:nvSpPr>
         <p:spPr>
           <a:xfrm>
-            <a:off x="914400" y="2057400"/>
-            <a:ext cx="2560320" cy="914400"/>
+            <a:off x="868680" y="1828800"/>
+            <a:ext cx="2103120" cy="777240"/>
           </a:xfrm>
           <a:prstGeom prst="rect">
             <a:avLst/>
@@ -11564,7 +11154,7 @@
               <a:buNone/>
             </a:pPr>
             <a:r>
-              <a:rPr lang="en-US" sz="5200" b="1" dirty="0">
+              <a:rPr lang="en-US" sz="4400" b="1" dirty="0">
                 <a:solidFill>
                   <a:srgbClr val="FFFFFF"/>
                 </a:solidFill>
@@ -11574,7 +11164,7 @@
               </a:rPr>
               <a:t>10</a:t>
             </a:r>
-            <a:endParaRPr lang="en-US" sz="5200" dirty="0"/>
+            <a:endParaRPr lang="en-US" sz="4400" dirty="0"/>
           </a:p>
         </p:txBody>
       </p:sp>
@@ -11586,8 +11176,8 @@
         </p:nvSpPr>
         <p:spPr>
           <a:xfrm>
-            <a:off x="914400" y="2971800"/>
-            <a:ext cx="2560320" cy="594360"/>
+            <a:off x="868680" y="2606040"/>
+            <a:ext cx="2148840" cy="502920"/>
           </a:xfrm>
           <a:prstGeom prst="rect">
             <a:avLst/>
@@ -11603,7 +11193,7 @@
               <a:buNone/>
             </a:pPr>
             <a:r>
-              <a:rPr lang="en-US" sz="1300" dirty="0">
+              <a:rPr lang="en-US" sz="1250" dirty="0">
                 <a:solidFill>
                   <a:srgbClr val="E0E7FF"/>
                 </a:solidFill>
@@ -11613,7 +11203,7 @@
               </a:rPr>
               <a:t>Indian languages plus English</a:t>
             </a:r>
-            <a:endParaRPr lang="en-US" sz="1300" dirty="0"/>
+            <a:endParaRPr lang="en-US" sz="1250" dirty="0"/>
           </a:p>
         </p:txBody>
       </p:sp>
@@ -11625,12 +11215,12 @@
         </p:nvSpPr>
         <p:spPr>
           <a:xfrm>
-            <a:off x="3931920" y="1874520"/>
-            <a:ext cx="3108960" cy="1783080"/>
+            <a:off x="3383280" y="1783080"/>
+            <a:ext cx="2560320" cy="1371600"/>
           </a:xfrm>
           <a:prstGeom prst="roundRect">
             <a:avLst>
-              <a:gd name="adj" fmla="val 6154"/>
+              <a:gd name="adj" fmla="val 8000"/>
             </a:avLst>
           </a:prstGeom>
           <a:solidFill>
@@ -11659,8 +11249,8 @@
         </p:nvSpPr>
         <p:spPr>
           <a:xfrm>
-            <a:off x="4206240" y="2057400"/>
-            <a:ext cx="2560320" cy="914400"/>
+            <a:off x="3611880" y="1828800"/>
+            <a:ext cx="2103120" cy="777240"/>
           </a:xfrm>
           <a:prstGeom prst="rect">
             <a:avLst/>
@@ -11676,7 +11266,7 @@
               <a:buNone/>
             </a:pPr>
             <a:r>
-              <a:rPr lang="en-US" sz="5200" b="1" dirty="0">
+              <a:rPr lang="en-US" sz="4400" b="1" dirty="0">
                 <a:solidFill>
                   <a:srgbClr val="6366F1"/>
                 </a:solidFill>
@@ -11686,7 +11276,7 @@
               </a:rPr>
               <a:t>17</a:t>
             </a:r>
-            <a:endParaRPr lang="en-US" sz="5200" dirty="0"/>
+            <a:endParaRPr lang="en-US" sz="4400" dirty="0"/>
           </a:p>
         </p:txBody>
       </p:sp>
@@ -11698,8 +11288,8 @@
         </p:nvSpPr>
         <p:spPr>
           <a:xfrm>
-            <a:off x="4206240" y="2971800"/>
-            <a:ext cx="2560320" cy="594360"/>
+            <a:off x="3611880" y="2606040"/>
+            <a:ext cx="2148840" cy="502920"/>
           </a:xfrm>
           <a:prstGeom prst="rect">
             <a:avLst/>
@@ -11715,7 +11305,7 @@
               <a:buNone/>
             </a:pPr>
             <a:r>
-              <a:rPr lang="en-US" sz="1300" dirty="0">
+              <a:rPr lang="en-US" sz="1250" dirty="0">
                 <a:solidFill>
                   <a:srgbClr val="64748B"/>
                 </a:solidFill>
@@ -11723,9 +11313,9 @@
                 <a:ea typeface="Calibri" pitchFamily="34" charset="-122"/>
                 <a:cs typeface="Calibri" pitchFamily="34" charset="-120"/>
               </a:rPr>
-              <a:t>interface languages including six international</a:t>
-            </a:r>
-            <a:endParaRPr lang="en-US" sz="1300" dirty="0"/>
+              <a:t>interface languages, six international</a:t>
+            </a:r>
+            <a:endParaRPr lang="en-US" sz="1250" dirty="0"/>
           </a:p>
         </p:txBody>
       </p:sp>
@@ -11737,12 +11327,12 @@
         </p:nvSpPr>
         <p:spPr>
           <a:xfrm>
-            <a:off x="640080" y="3886200"/>
-            <a:ext cx="3108960" cy="1783080"/>
+            <a:off x="6126480" y="1783080"/>
+            <a:ext cx="2560320" cy="1371600"/>
           </a:xfrm>
           <a:prstGeom prst="roundRect">
             <a:avLst>
-              <a:gd name="adj" fmla="val 6154"/>
+              <a:gd name="adj" fmla="val 8000"/>
             </a:avLst>
           </a:prstGeom>
           <a:solidFill>
@@ -11771,8 +11361,8 @@
         </p:nvSpPr>
         <p:spPr>
           <a:xfrm>
-            <a:off x="914400" y="4069080"/>
-            <a:ext cx="2560320" cy="914400"/>
+            <a:off x="6355080" y="1828800"/>
+            <a:ext cx="2103120" cy="777240"/>
           </a:xfrm>
           <a:prstGeom prst="rect">
             <a:avLst/>
@@ -11788,7 +11378,7 @@
               <a:buNone/>
             </a:pPr>
             <a:r>
-              <a:rPr lang="en-US" sz="5200" b="1" dirty="0">
+              <a:rPr lang="en-US" sz="4400" b="1" dirty="0">
                 <a:solidFill>
                   <a:srgbClr val="6366F1"/>
                 </a:solidFill>
@@ -11798,7 +11388,7 @@
               </a:rPr>
               <a:t>20+</a:t>
             </a:r>
-            <a:endParaRPr lang="en-US" sz="5200" dirty="0"/>
+            <a:endParaRPr lang="en-US" sz="4400" dirty="0"/>
           </a:p>
         </p:txBody>
       </p:sp>
@@ -11810,8 +11400,8 @@
         </p:nvSpPr>
         <p:spPr>
           <a:xfrm>
-            <a:off x="914400" y="4983480"/>
-            <a:ext cx="2560320" cy="594360"/>
+            <a:off x="6355080" y="2606040"/>
+            <a:ext cx="2148840" cy="502920"/>
           </a:xfrm>
           <a:prstGeom prst="rect">
             <a:avLst/>
@@ -11827,7 +11417,7 @@
               <a:buNone/>
             </a:pPr>
             <a:r>
-              <a:rPr lang="en-US" sz="1300" dirty="0">
+              <a:rPr lang="en-US" sz="1250" dirty="0">
                 <a:solidFill>
                   <a:srgbClr val="64748B"/>
                 </a:solidFill>
@@ -11837,7 +11427,7 @@
               </a:rPr>
               <a:t>states in the Indian seed data</a:t>
             </a:r>
-            <a:endParaRPr lang="en-US" sz="1300" dirty="0"/>
+            <a:endParaRPr lang="en-US" sz="1250" dirty="0"/>
           </a:p>
         </p:txBody>
       </p:sp>
@@ -11849,12 +11439,12 @@
         </p:nvSpPr>
         <p:spPr>
           <a:xfrm>
-            <a:off x="3931920" y="3886200"/>
-            <a:ext cx="3108960" cy="1783080"/>
+            <a:off x="8869680" y="1783080"/>
+            <a:ext cx="2560320" cy="1371600"/>
           </a:xfrm>
           <a:prstGeom prst="roundRect">
             <a:avLst>
-              <a:gd name="adj" fmla="val 6154"/>
+              <a:gd name="adj" fmla="val 8000"/>
             </a:avLst>
           </a:prstGeom>
           <a:solidFill>
@@ -11883,8 +11473,8 @@
         </p:nvSpPr>
         <p:spPr>
           <a:xfrm>
-            <a:off x="4206240" y="4069080"/>
-            <a:ext cx="2560320" cy="914400"/>
+            <a:off x="9098280" y="1828800"/>
+            <a:ext cx="2103120" cy="777240"/>
           </a:xfrm>
           <a:prstGeom prst="rect">
             <a:avLst/>
@@ -11900,7 +11490,7 @@
               <a:buNone/>
             </a:pPr>
             <a:r>
-              <a:rPr lang="en-US" sz="5200" b="1" dirty="0">
+              <a:rPr lang="en-US" sz="4400" b="1" dirty="0">
                 <a:solidFill>
                   <a:srgbClr val="6366F1"/>
                 </a:solidFill>
@@ -11910,7 +11500,7 @@
               </a:rPr>
               <a:t>5</a:t>
             </a:r>
-            <a:endParaRPr lang="en-US" sz="5200" dirty="0"/>
+            <a:endParaRPr lang="en-US" sz="4400" dirty="0"/>
           </a:p>
         </p:txBody>
       </p:sp>
@@ -11922,8 +11512,8 @@
         </p:nvSpPr>
         <p:spPr>
           <a:xfrm>
-            <a:off x="4206240" y="4983480"/>
-            <a:ext cx="2560320" cy="594360"/>
+            <a:off x="9098280" y="2606040"/>
+            <a:ext cx="2148840" cy="502920"/>
           </a:xfrm>
           <a:prstGeom prst="rect">
             <a:avLst/>
@@ -11939,7 +11529,7 @@
               <a:buNone/>
             </a:pPr>
             <a:r>
-              <a:rPr lang="en-US" sz="1300" dirty="0">
+              <a:rPr lang="en-US" sz="1250" dirty="0">
                 <a:solidFill>
                   <a:srgbClr val="64748B"/>
                 </a:solidFill>
@@ -11949,7 +11539,7 @@
               </a:rPr>
               <a:t>BRICS countries in the comparison view</a:t>
             </a:r>
-            <a:endParaRPr lang="en-US" sz="1300" dirty="0"/>
+            <a:endParaRPr lang="en-US" sz="1250" dirty="0"/>
           </a:p>
         </p:txBody>
       </p:sp>
@@ -11961,12 +11551,70 @@
         </p:nvSpPr>
         <p:spPr>
           <a:xfrm>
-            <a:off x="7406640" y="1874520"/>
-            <a:ext cx="4114800" cy="3794760"/>
+            <a:off x="640080" y="3429000"/>
+            <a:ext cx="5687568" cy="2706624"/>
           </a:xfrm>
           <a:prstGeom prst="roundRect">
             <a:avLst>
-              <a:gd name="adj" fmla="val 2892"/>
+              <a:gd name="adj" fmla="val 3378"/>
+            </a:avLst>
+          </a:prstGeom>
+          <a:solidFill>
+            <a:srgbClr val="0F0F1A"/>
+          </a:solidFill>
+          <a:ln w="9525">
+            <a:solidFill>
+              <a:srgbClr val="E2E8F0"/>
+            </a:solidFill>
+            <a:prstDash val="solid"/>
+          </a:ln>
+          <a:effectLst>
+            <a:outerShdw sx="100000" sy="100000" kx="0" ky="0" algn="bl" rotWithShape="0" blurRad="101600" dist="25400" dir="5400000">
+              <a:srgbClr val="000000">
+                <a:alpha val="12000"/>
+              </a:srgbClr>
+            </a:outerShdw>
+          </a:effectLst>
+        </p:spPr>
+      </p:sp>
+      <p:pic>
+        <p:nvPicPr>
+          <p:cNvPr id="17" name="Image 0" descr="/tmp/deck/shots/brics.png">    </p:cNvPr>
+          <p:cNvPicPr>
+            <a:picLocks noChangeAspect="1"/>
+          </p:cNvPicPr>
+          <p:nvPr/>
+        </p:nvPicPr>
+        <p:blipFill>
+          <a:blip r:embed="rId1"/>
+          <a:stretch>
+            <a:fillRect/>
+          </a:stretch>
+        </p:blipFill>
+        <p:spPr>
+          <a:xfrm>
+            <a:off x="694944" y="3483864"/>
+            <a:ext cx="5577840" cy="2594344"/>
+          </a:xfrm>
+          <a:prstGeom prst="rect">
+            <a:avLst/>
+          </a:prstGeom>
+        </p:spPr>
+      </p:pic>
+      <p:sp>
+        <p:nvSpPr>
+          <p:cNvPr id="18" name="Shape 15"/>
+          <p:cNvSpPr/>
+          <p:nvPr/>
+        </p:nvSpPr>
+        <p:spPr>
+          <a:xfrm>
+            <a:off x="6583680" y="3429000"/>
+            <a:ext cx="4983480" cy="2706624"/>
+          </a:xfrm>
+          <a:prstGeom prst="roundRect">
+            <a:avLst>
+              <a:gd name="adj" fmla="val 4054"/>
             </a:avLst>
           </a:prstGeom>
           <a:solidFill>
@@ -11989,14 +11637,14 @@
       </p:sp>
       <p:sp>
         <p:nvSpPr>
-          <p:cNvPr id="17" name="Text 15"/>
-          <p:cNvSpPr txBox="1"/>
-          <p:nvPr/>
-        </p:nvSpPr>
-        <p:spPr>
-          <a:xfrm>
-            <a:off x="7680960" y="2011680"/>
-            <a:ext cx="3657600" cy="365760"/>
+          <p:cNvPr id="19" name="Text 16"/>
+          <p:cNvSpPr txBox="1"/>
+          <p:nvPr/>
+        </p:nvSpPr>
+        <p:spPr>
+          <a:xfrm>
+            <a:off x="6858000" y="3547872"/>
+            <a:ext cx="4480560" cy="320040"/>
           </a:xfrm>
           <a:prstGeom prst="rect">
             <a:avLst/>
@@ -12012,7 +11660,7 @@
               <a:buNone/>
             </a:pPr>
             <a:r>
-              <a:rPr lang="en-US" sz="1800" b="1" dirty="0">
+              <a:rPr lang="en-US" sz="1600" b="1" dirty="0">
                 <a:solidFill>
                   <a:srgbClr val="0F172A"/>
                 </a:solidFill>
@@ -12022,20 +11670,20 @@
               </a:rPr>
               <a:t>Languages</a:t>
             </a:r>
-            <a:endParaRPr lang="en-US" sz="1800" dirty="0"/>
-          </a:p>
-        </p:txBody>
-      </p:sp>
-      <p:sp>
-        <p:nvSpPr>
-          <p:cNvPr id="18" name="Text 16"/>
-          <p:cNvSpPr txBox="1"/>
-          <p:nvPr/>
-        </p:nvSpPr>
-        <p:spPr>
-          <a:xfrm>
-            <a:off x="7680960" y="2423160"/>
-            <a:ext cx="3611880" cy="1097280"/>
+            <a:endParaRPr lang="en-US" sz="1600" dirty="0"/>
+          </a:p>
+        </p:txBody>
+      </p:sp>
+      <p:sp>
+        <p:nvSpPr>
+          <p:cNvPr id="20" name="Text 17"/>
+          <p:cNvSpPr txBox="1"/>
+          <p:nvPr/>
+        </p:nvSpPr>
+        <p:spPr>
+          <a:xfrm>
+            <a:off x="6858000" y="3913632"/>
+            <a:ext cx="4480560" cy="822960"/>
           </a:xfrm>
           <a:prstGeom prst="rect">
             <a:avLst/>
@@ -12051,7 +11699,7 @@
               <a:buNone/>
             </a:pPr>
             <a:r>
-              <a:rPr lang="en-US" sz="1400" dirty="0">
+              <a:rPr lang="en-US" sz="1250" dirty="0">
                 <a:solidFill>
                   <a:srgbClr val="64748B"/>
                 </a:solidFill>
@@ -12061,20 +11709,20 @@
               </a:rPr>
               <a:t>Hindi, Bengali, Tamil, Telugu, Marathi, Gujarati, Kannada, Malayalam, Punjabi, Odia and English.</a:t>
             </a:r>
-            <a:endParaRPr lang="en-US" sz="1400" dirty="0"/>
-          </a:p>
-        </p:txBody>
-      </p:sp>
-      <p:sp>
-        <p:nvSpPr>
-          <p:cNvPr id="19" name="Text 17"/>
-          <p:cNvSpPr txBox="1"/>
-          <p:nvPr/>
-        </p:nvSpPr>
-        <p:spPr>
-          <a:xfrm>
-            <a:off x="7680960" y="3611880"/>
-            <a:ext cx="3611880" cy="1188720"/>
+            <a:endParaRPr lang="en-US" sz="1250" dirty="0"/>
+          </a:p>
+        </p:txBody>
+      </p:sp>
+      <p:sp>
+        <p:nvSpPr>
+          <p:cNvPr id="21" name="Text 18"/>
+          <p:cNvSpPr txBox="1"/>
+          <p:nvPr/>
+        </p:nvSpPr>
+        <p:spPr>
+          <a:xfrm>
+            <a:off x="6858000" y="4754880"/>
+            <a:ext cx="4480560" cy="822960"/>
           </a:xfrm>
           <a:prstGeom prst="rect">
             <a:avLst/>
@@ -12090,7 +11738,7 @@
               <a:buNone/>
             </a:pPr>
             <a:r>
-              <a:rPr lang="en-US" sz="1400" dirty="0">
+              <a:rPr lang="en-US" sz="1250" dirty="0">
                 <a:solidFill>
                   <a:srgbClr val="0F172A"/>
                 </a:solidFill>
@@ -12098,38 +11746,38 @@
                 <a:ea typeface="Calibri" pitchFamily="34" charset="-122"/>
                 <a:cs typeface="Calibri" pitchFamily="34" charset="-120"/>
               </a:rPr>
-              <a:t>No language picker for citizens: Gemini detects the language and stores the original text with an English translation.</a:t>
-            </a:r>
-            <a:endParaRPr lang="en-US" sz="1400" dirty="0"/>
-          </a:p>
-        </p:txBody>
-      </p:sp>
-      <p:sp>
-        <p:nvSpPr>
-          <p:cNvPr id="20" name="Text 18"/>
-          <p:cNvSpPr txBox="1"/>
-          <p:nvPr/>
-        </p:nvSpPr>
-        <p:spPr>
-          <a:xfrm>
-            <a:off x="7680960" y="4800600"/>
-            <a:ext cx="3611880" cy="731520"/>
-          </a:xfrm>
-          <a:prstGeom prst="rect">
-            <a:avLst/>
-          </a:prstGeom>
-          <a:noFill/>
-          <a:ln/>
-        </p:spPr>
-        <p:txBody>
-          <a:bodyPr wrap="square" lIns="0" tIns="0" rIns="0" bIns="0" rtlCol="0" anchor="t"/>
-          <a:lstStyle/>
-          <a:p>
-            <a:pPr indent="0" marL="0">
-              <a:buNone/>
-            </a:pPr>
-            <a:r>
-              <a:rPr lang="en-US" sz="1200" i="1" dirty="0">
+              <a:t>Gemini detects the language, so citizens never pick one. Original text and an English translation are both stored.</a:t>
+            </a:r>
+            <a:endParaRPr lang="en-US" sz="1250" dirty="0"/>
+          </a:p>
+        </p:txBody>
+      </p:sp>
+      <p:sp>
+        <p:nvSpPr>
+          <p:cNvPr id="22" name="Text 19"/>
+          <p:cNvSpPr txBox="1"/>
+          <p:nvPr/>
+        </p:nvSpPr>
+        <p:spPr>
+          <a:xfrm>
+            <a:off x="6858000" y="5715000"/>
+            <a:ext cx="4480560" cy="274320"/>
+          </a:xfrm>
+          <a:prstGeom prst="rect">
+            <a:avLst/>
+          </a:prstGeom>
+          <a:noFill/>
+          <a:ln/>
+        </p:spPr>
+        <p:txBody>
+          <a:bodyPr wrap="square" lIns="0" tIns="0" rIns="0" bIns="0" rtlCol="0" anchor="ctr"/>
+          <a:lstStyle/>
+          <a:p>
+            <a:pPr indent="0" marL="0">
+              <a:buNone/>
+            </a:pPr>
+            <a:r>
+              <a:rPr lang="en-US" sz="1100" i="1" dirty="0">
                 <a:solidFill>
                   <a:srgbClr val="64748B"/>
                 </a:solidFill>
@@ -12137,22 +11785,22 @@
                 <a:ea typeface="Calibri" pitchFamily="34" charset="-122"/>
                 <a:cs typeface="Calibri" pitchFamily="34" charset="-120"/>
               </a:rPr>
-              <a:t>Architecture is region-agnostic, so adding a state is data, not code.</a:t>
-            </a:r>
-            <a:endParaRPr lang="en-US" sz="1200" dirty="0"/>
+              <a:t>BRICS view uses synthetic data.</a:t>
+            </a:r>
+            <a:endParaRPr lang="en-US" sz="1100" dirty="0"/>
           </a:p>
         </p:txBody>
       </p:sp>
       <p:pic>
         <p:nvPicPr>
-          <p:cNvPr id="21" name="Image 0" descr="/tmp/deck/mark.png">    </p:cNvPr>
+          <p:cNvPr id="23" name="Image 1" descr="/tmp/deck/mark.png">    </p:cNvPr>
           <p:cNvPicPr>
             <a:picLocks noChangeAspect="1"/>
           </p:cNvPicPr>
           <p:nvPr/>
         </p:nvPicPr>
         <p:blipFill>
-          <a:blip r:embed="rId1"/>
+          <a:blip r:embed="rId2"/>
           <a:stretch>
             <a:fillRect/>
           </a:stretch>
@@ -12169,7 +11817,7 @@
       </p:pic>
       <p:sp>
         <p:nvSpPr>
-          <p:cNvPr id="22" name="Text 19"/>
+          <p:cNvPr id="24" name="Text 20"/>
           <p:cNvSpPr txBox="1"/>
           <p:nvPr/>
         </p:nvSpPr>
@@ -12208,7 +11856,7 @@
       </p:sp>
       <p:sp>
         <p:nvSpPr>
-          <p:cNvPr id="23" name="Text 20"/>
+          <p:cNvPr id="25" name="Text 21"/>
           <p:cNvSpPr txBox="1"/>
           <p:nvPr/>
         </p:nvSpPr>

</xml_diff>